<commit_message>
Clarify Jira setup role and add Governance Call to build phase
- Step 4: AI Enablement Team sets up Jira project and folder structure
  (epics, stories, and backlog are defined later during the build phase)
- Step 5: Added Governance Call task — AI Forward Engineer presents the
  solution, walks through architecture, and completes risk assessment
  before launch proceeds to GTM

Applied across HTML, DOCX, and PPTX.

https://claude.ai/code/session_014sYowDSYncDohFg42MDKfr
</commit_message>
<xml_diff>
--- a/AI-Use-Case-to-GTM-Step-Guide.pptx
+++ b/AI-Use-Case-to-GTM-Step-Guide.pptx
@@ -8072,7 +8072,7 @@
                           </a:solidFill>
                           <a:latin typeface="Calibri"/>
                         </a:rPr>
-                        <a:t>Set Up Jira</a:t>
+                        <a:t>Set Up Jira &amp; Project Folder</a:t>
                       </a:r>
                       <a:r>
                         <a:rPr sz="1200">
@@ -8081,7 +8081,7 @@
                           </a:solidFill>
                           <a:latin typeface="Calibri"/>
                         </a:rPr>
-                        <a:t> — Create project, epics, stories &amp; sprint backlog</a:t>
+                        <a:t> — Create Jira project and folder structure (epics, stories &amp; backlog defined during build)</a:t>
                       </a:r>
                     </a:p>
                   </a:txBody>
@@ -8454,7 +8454,7 @@
         </p:nvGraphicFramePr>
         <p:xfrm>
           <a:off x="731520" y="1097280"/>
-          <a:ext cx="10698479" cy="2194560"/>
+          <a:ext cx="10698479" cy="2560320"/>
         </p:xfrm>
         <a:graphic>
           <a:graphicData uri="http://schemas.openxmlformats.org/drawingml/2006/table">
@@ -8835,6 +8835,71 @@
                   <a:tcPr>
                     <a:solidFill>
                       <a:srgbClr val="F3F4F6"/>
+                    </a:solidFill>
+                  </a:tcPr>
+                </a:tc>
+              </a:tr>
+              <a:tr h="365760">
+                <a:tc>
+                  <a:txBody>
+                    <a:bodyPr/>
+                    <a:lstStyle/>
+                    <a:p>
+                      <a:r>
+                        <a:rPr sz="1200">
+                          <a:solidFill>
+                            <a:srgbClr val="1A1A2E"/>
+                          </a:solidFill>
+                          <a:latin typeface="Calibri"/>
+                        </a:rPr>
+                        <a:t>Present solution on </a:t>
+                      </a:r>
+                      <a:r>
+                        <a:rPr sz="1200" b="1">
+                          <a:solidFill>
+                            <a:srgbClr val="1A1A2E"/>
+                          </a:solidFill>
+                          <a:latin typeface="Calibri"/>
+                        </a:rPr>
+                        <a:t>Governance Call</a:t>
+                      </a:r>
+                      <a:r>
+                        <a:rPr sz="1200">
+                          <a:solidFill>
+                            <a:srgbClr val="1A1A2E"/>
+                          </a:solidFill>
+                          <a:latin typeface="Calibri"/>
+                        </a:rPr>
+                        <a:t> — explain solution, walk through architecture &amp; complete risk assessment before launch</a:t>
+                      </a:r>
+                    </a:p>
+                  </a:txBody>
+                  <a:tcPr>
+                    <a:solidFill>
+                      <a:srgbClr val="FFFFFF"/>
+                    </a:solidFill>
+                  </a:tcPr>
+                </a:tc>
+                <a:tc>
+                  <a:txBody>
+                    <a:bodyPr/>
+                    <a:lstStyle/>
+                    <a:p>
+                      <a:pPr algn="r"/>
+                      <a:r>
+                        <a:rPr sz="1100" b="1">
+                          <a:solidFill>
+                            <a:srgbClr val="2B477A"/>
+                          </a:solidFill>
+                          <a:latin typeface="Calibri"/>
+                        </a:rPr>
+                        <a:t>AI Forward Engineer</a:t>
+                      </a:r>
+                    </a:p>
+                  </a:txBody>
+                  <a:tcPr>
+                    <a:solidFill>
+                      <a:srgbClr val="FFFFFF"/>
                     </a:solidFill>
                   </a:tcPr>
                 </a:tc>

</xml_diff>

<commit_message>
Refine task wording and role assignments across all formats
- Step 3: "Determine scope POC/MVP/Full Build" → "Evaluate use case
  based on business value & tech depth"
- Step 4: Remove "via Retain" from resource allocation
- Step 5: Add AI Champion to sprint cycles task (alongside AI Fwd
  Engineer and AI Enablement Team)
- Step 8: Add AI Enablement Team to client feedback capture task
  (alongside AI Champion and Domain Leader)

https://claude.ai/code/session_014sYowDSYncDohFg42MDKfr
</commit_message>
<xml_diff>
--- a/AI-Use-Case-to-GTM-Step-Guide.pptx
+++ b/AI-Use-Case-to-GTM-Step-Guide.pptx
@@ -5009,7 +5009,7 @@
                           </a:solidFill>
                           <a:latin typeface="Calibri"/>
                         </a:rPr>
-                        <a:t>AI Champion + Domain Leader</a:t>
+                        <a:t>AI Champion + Domain Leader + AI Enablement</a:t>
                       </a:r>
                     </a:p>
                   </a:txBody>
@@ -7381,7 +7381,7 @@
                           </a:solidFill>
                           <a:latin typeface="Calibri"/>
                         </a:rPr>
-                        <a:t>Determine scope: </a:t>
+                        <a:t/>
                       </a:r>
                       <a:r>
                         <a:rPr sz="1200" b="1">
@@ -7390,7 +7390,7 @@
                           </a:solidFill>
                           <a:latin typeface="Calibri"/>
                         </a:rPr>
-                        <a:t>POC / MVP / Full Build</a:t>
+                        <a:t>Evaluate use case</a:t>
                       </a:r>
                       <a:r>
                         <a:rPr sz="1200">
@@ -8146,7 +8146,7 @@
                           </a:solidFill>
                           <a:latin typeface="Calibri"/>
                         </a:rPr>
-                        <a:t> — Assign AI Forward Engineers via Retain</a:t>
+                        <a:t> — Assign AI Forward Engineers</a:t>
                       </a:r>
                     </a:p>
                   </a:txBody>
@@ -8633,7 +8633,7 @@
                           </a:solidFill>
                           <a:latin typeface="Calibri"/>
                         </a:rPr>
-                        <a:t>AI Fwd Engineer + AI Enablement Team</a:t>
+                        <a:t>AI Fwd Engineer + AI Enablement + AI Champion</a:t>
                       </a:r>
                     </a:p>
                   </a:txBody>

</xml_diff>